<commit_message>
Update vision.pptx with Lopez de Prado reference and historical handover failure
Co-Authored-By: Claude Sonnet 4.6 <noreply@anthropic.com>
</commit_message>
<xml_diff>
--- a/vision.pptx
+++ b/vision.pptx
@@ -8372,7 +8372,7 @@
                   <a:srgbClr val="E5E7EB"/>
                 </a:solidFill>
               </a:rPr>
-              <a:t>▸  Every change to a live strategy risked restarting the process</a:t>
+              <a:t>▸  PyTorch and modern ML simply cannot be reimplemented in C++</a:t>
             </a:r>
           </a:p>
           <a:p>
@@ -8390,7 +8390,7 @@
                   <a:srgbClr val="E5E7EB"/>
                 </a:solidFill>
               </a:rPr>
-              <a:t>▸  PyTorch and modern ML simply cannot be reimplemented in C++</a:t>
+              <a:t>▸  History's verdict: the kitchen was never built</a:t>
             </a:r>
           </a:p>
           <a:p>
@@ -8408,7 +8408,7 @@
                   <a:srgbClr val="E5E7EB"/>
                 </a:solidFill>
               </a:rPr>
-              <a:t>▸  When things go wrong, accountability diffuses across teams — nobody owns it</a:t>
+              <a:t>▸  Essential tools reinvented independently by every team — data APIs, portfolio tools, analytics</a:t>
             </a:r>
           </a:p>
           <a:p>
@@ -8426,7 +8426,43 @@
                   <a:srgbClr val="E5E7EB"/>
                 </a:solidFill>
               </a:rPr>
-              <a:t>▸  The checkerboard: when teams build together, they own together</a:t>
+              <a:t>▸  Result: a sprawling collection of overlapping partial solutions, each owned by whoever wrote it</a:t>
+            </a:r>
+          </a:p>
+          <a:p>
+            <a:pPr>
+              <a:spcBef>
+                <a:spcPts val="400"/>
+              </a:spcBef>
+              <a:spcAft>
+                <a:spcPts val="400"/>
+              </a:spcAft>
+            </a:pPr>
+            <a:r>
+              <a:rPr sz="1700">
+                <a:solidFill>
+                  <a:srgbClr val="E5E7EB"/>
+                </a:solidFill>
+              </a:rPr>
+              <a:t>▸  When things go wrong, accountability diffuses — nobody owns it</a:t>
+            </a:r>
+          </a:p>
+          <a:p>
+            <a:pPr>
+              <a:spcBef>
+                <a:spcPts val="400"/>
+              </a:spcBef>
+              <a:spcAft>
+                <a:spcPts val="400"/>
+              </a:spcAft>
+            </a:pPr>
+            <a:r>
+              <a:rPr sz="1700">
+                <a:solidFill>
+                  <a:srgbClr val="E5E7EB"/>
+                </a:solidFill>
+              </a:rPr>
+              <a:t>▸  Discussed by Marcos Lopez de Prado; put into practice at ADIA's Team Q</a:t>
             </a:r>
           </a:p>
         </p:txBody>
@@ -8847,7 +8883,25 @@
                   <a:srgbClr val="E5E7EB"/>
                 </a:solidFill>
               </a:rPr>
-              <a:t>▸  Better image: the professional kitchen</a:t>
+              <a:t>▸  Lopez de Prado's car factory analogy: appealing but misleading</a:t>
+            </a:r>
+          </a:p>
+          <a:p>
+            <a:pPr>
+              <a:spcBef>
+                <a:spcPts val="400"/>
+              </a:spcBef>
+              <a:spcAft>
+                <a:spcPts val="400"/>
+              </a:spcAft>
+            </a:pPr>
+            <a:r>
+              <a:rPr sz="1700">
+                <a:solidFill>
+                  <a:srgbClr val="E5E7EB"/>
+                </a:solidFill>
+              </a:rPr>
+              <a:t>▸  Better image: the professional kitchen — familiar, collaborative, quality at every step</a:t>
             </a:r>
           </a:p>
           <a:p>

</xml_diff>